<commit_message>
docs: purge all remaining inverted-positioning residues — 3 pptx covers patched at XML level, builders/workspaces/trees/notes aligned to kernel-first framing
</commit_message>
<xml_diff>
--- a/docs/ppt/detailed/laos-detailed-ppt-master.pptx
+++ b/docs/ppt/detailed/laos-detailed-ppt-master.pptx
@@ -364,7 +364,7 @@
             <a:pPr/>
             <a:r>
               <a:rPr lang="zh-CN" dirty="0"/>
-              <a:t>各位好，这一场是 laos 项目的详细技术深潜。laos 把自己定义为 Linux AgentOS——面向 AI Agent 的用户态操作系统，一句话就是屏幕上这个等式：Linux kernel 加 Agent 加 MCP。今天是 v0.12.0，2026 年 10 月 5 日的仓库真实状态：765 项测试全绿，15 个 MCP 驱动，30 天里发了 12 个版本。右侧这圈轨道上的八个点，就是后面第六页要展开的八环闸门链，先留个印象。</a:t>
+              <a:t>各位好，这一场是 laos 项目的详细技术深潜。laos 把自己定义为 Linux AgentOS——Linux 内核的 Agent 扩展（用户态 · 零内核改动），一句话就是屏幕上这个等式：Linux kernel 加 Agent 加 MCP。今天是 v0.12.0，2026 年 10 月 5 日的仓库真实状态：765 项测试全绿，15 个 MCP 驱动，30 天里发了 12 个版本。右侧这圈轨道上的八个点，就是后面第六页要展开的八环闸门链，先留个印象。</a:t>
             </a:r>
           </a:p>
         </p:txBody>
@@ -2101,6 +2101,10 @@
               </a:solidFill>
             </a:ln>
           </p:spPr>
+          <p:txBody>
+            <a:bodyPr/>
+            <a:p/>
+          </p:txBody>
         </p:sp>
       </p:grpSp>
       <p:grpSp>
@@ -2138,6 +2142,10 @@
               <a:noFill/>
             </a:ln>
           </p:spPr>
+          <p:txBody>
+            <a:bodyPr/>
+            <a:p/>
+          </p:txBody>
         </p:sp>
         <p:sp>
           <p:nvSpPr>
@@ -2254,7 +2262,7 @@
                   <a:ea typeface="+mn-ea"/>
                   <a:cs typeface="+mn-cs"/>
                 </a:rPr>
-                <a:t>面向 AI Agent 的用户态操作系统 · 详细技术深潜</a:t>
+                <a:t>Linux 内核的 Agent 扩展（用户态 · 零内核改动）· 详细技术深潜</a:t>
               </a:r>
             </a:p>
           </p:txBody>
@@ -2295,6 +2303,10 @@
               <a:noFill/>
             </a:ln>
           </p:spPr>
+          <p:txBody>
+            <a:bodyPr/>
+            <a:p/>
+          </p:txBody>
         </p:sp>
         <p:sp>
           <p:nvSpPr>
@@ -2466,6 +2478,10 @@
               </a:solidFill>
             </a:ln>
           </p:spPr>
+          <p:txBody>
+            <a:bodyPr/>
+            <a:p/>
+          </p:txBody>
         </p:sp>
         <p:sp>
           <p:nvSpPr>
@@ -2582,6 +2598,10 @@
               </a:solidFill>
             </a:ln>
           </p:spPr>
+          <p:txBody>
+            <a:bodyPr/>
+            <a:p/>
+          </p:txBody>
         </p:sp>
         <p:sp>
           <p:nvSpPr>
@@ -2754,6 +2774,10 @@
               </a:solidFill>
             </a:ln>
           </p:spPr>
+          <p:txBody>
+            <a:bodyPr/>
+            <a:p/>
+          </p:txBody>
         </p:sp>
         <p:sp>
           <p:nvSpPr>
@@ -2776,6 +2800,10 @@
               </a:solidFill>
             </a:ln>
           </p:spPr>
+          <p:txBody>
+            <a:bodyPr/>
+            <a:p/>
+          </p:txBody>
         </p:sp>
         <p:sp>
           <p:nvSpPr>
@@ -2798,6 +2826,10 @@
               </a:solidFill>
             </a:ln>
           </p:spPr>
+          <p:txBody>
+            <a:bodyPr/>
+            <a:p/>
+          </p:txBody>
         </p:sp>
         <p:sp>
           <p:nvSpPr>
@@ -2820,6 +2852,10 @@
               <a:noFill/>
             </a:ln>
           </p:spPr>
+          <p:txBody>
+            <a:bodyPr/>
+            <a:p/>
+          </p:txBody>
         </p:sp>
         <p:sp>
           <p:nvSpPr>
@@ -2882,6 +2918,10 @@
               <a:noFill/>
             </a:ln>
           </p:spPr>
+          <p:txBody>
+            <a:bodyPr/>
+            <a:p/>
+          </p:txBody>
         </p:sp>
         <p:sp>
           <p:nvSpPr>
@@ -2904,6 +2944,10 @@
               <a:noFill/>
             </a:ln>
           </p:spPr>
+          <p:txBody>
+            <a:bodyPr/>
+            <a:p/>
+          </p:txBody>
         </p:sp>
         <p:sp>
           <p:nvSpPr>
@@ -2926,6 +2970,10 @@
               <a:noFill/>
             </a:ln>
           </p:spPr>
+          <p:txBody>
+            <a:bodyPr/>
+            <a:p/>
+          </p:txBody>
         </p:sp>
         <p:sp>
           <p:nvSpPr>
@@ -2948,6 +2996,10 @@
               <a:noFill/>
             </a:ln>
           </p:spPr>
+          <p:txBody>
+            <a:bodyPr/>
+            <a:p/>
+          </p:txBody>
         </p:sp>
         <p:sp>
           <p:nvSpPr>
@@ -2970,6 +3022,10 @@
               <a:noFill/>
             </a:ln>
           </p:spPr>
+          <p:txBody>
+            <a:bodyPr/>
+            <a:p/>
+          </p:txBody>
         </p:sp>
         <p:sp>
           <p:nvSpPr>
@@ -2992,6 +3048,10 @@
               <a:noFill/>
             </a:ln>
           </p:spPr>
+          <p:txBody>
+            <a:bodyPr/>
+            <a:p/>
+          </p:txBody>
         </p:sp>
         <p:sp>
           <p:nvSpPr>
@@ -3014,6 +3074,10 @@
               <a:noFill/>
             </a:ln>
           </p:spPr>
+          <p:txBody>
+            <a:bodyPr/>
+            <a:p/>
+          </p:txBody>
         </p:sp>
         <p:sp>
           <p:nvSpPr>
@@ -3036,6 +3100,10 @@
               <a:noFill/>
             </a:ln>
           </p:spPr>
+          <p:txBody>
+            <a:bodyPr/>
+            <a:p/>
+          </p:txBody>
         </p:sp>
         <p:sp>
           <p:nvSpPr>
@@ -3127,6 +3195,10 @@
               </a:solidFill>
             </a:ln>
           </p:spPr>
+          <p:txBody>
+            <a:bodyPr/>
+            <a:p/>
+          </p:txBody>
         </p:sp>
         <p:sp>
           <p:nvSpPr>
@@ -3374,6 +3446,10 @@
               </a:solidFill>
             </a:ln>
           </p:spPr>
+          <p:txBody>
+            <a:bodyPr/>
+            <a:p/>
+          </p:txBody>
         </p:sp>
       </p:grpSp>
       <p:grpSp>
@@ -3506,6 +3582,10 @@
               <a:noFill/>
             </a:ln>
           </p:spPr>
+          <p:txBody>
+            <a:bodyPr/>
+            <a:p/>
+          </p:txBody>
         </p:sp>
         <p:sp>
           <p:nvSpPr>
@@ -3663,6 +3743,10 @@
               <a:noFill/>
             </a:ln>
           </p:spPr>
+          <p:txBody>
+            <a:bodyPr/>
+            <a:p/>
+          </p:txBody>
         </p:sp>
         <p:sp>
           <p:nvSpPr>
@@ -3820,6 +3904,10 @@
               <a:noFill/>
             </a:ln>
           </p:spPr>
+          <p:txBody>
+            <a:bodyPr/>
+            <a:p/>
+          </p:txBody>
         </p:sp>
         <p:sp>
           <p:nvSpPr>
@@ -3977,6 +4065,10 @@
               <a:noFill/>
             </a:ln>
           </p:spPr>
+          <p:txBody>
+            <a:bodyPr/>
+            <a:p/>
+          </p:txBody>
         </p:sp>
         <p:sp>
           <p:nvSpPr>
@@ -4134,6 +4226,10 @@
               <a:noFill/>
             </a:ln>
           </p:spPr>
+          <p:txBody>
+            <a:bodyPr/>
+            <a:p/>
+          </p:txBody>
         </p:sp>
         <p:sp>
           <p:nvSpPr>
@@ -4291,6 +4387,10 @@
               <a:noFill/>
             </a:ln>
           </p:spPr>
+          <p:txBody>
+            <a:bodyPr/>
+            <a:p/>
+          </p:txBody>
         </p:sp>
         <p:sp>
           <p:nvSpPr>
@@ -4462,6 +4562,10 @@
               </a:solidFill>
             </a:ln>
           </p:spPr>
+          <p:txBody>
+            <a:bodyPr/>
+            <a:p/>
+          </p:txBody>
         </p:sp>
         <p:sp>
           <p:nvSpPr>
@@ -4709,6 +4813,10 @@
               </a:solidFill>
             </a:ln>
           </p:spPr>
+          <p:txBody>
+            <a:bodyPr/>
+            <a:p/>
+          </p:txBody>
         </p:sp>
       </p:grpSp>
       <p:grpSp>
@@ -4921,6 +5029,10 @@
               <a:noFill/>
             </a:ln>
           </p:spPr>
+          <p:txBody>
+            <a:bodyPr/>
+            <a:p/>
+          </p:txBody>
         </p:sp>
         <p:sp>
           <p:nvSpPr>
@@ -4983,6 +5095,10 @@
               <a:noFill/>
             </a:ln>
           </p:spPr>
+          <p:txBody>
+            <a:bodyPr/>
+            <a:p/>
+          </p:txBody>
         </p:sp>
         <p:sp>
           <p:nvSpPr>
@@ -5008,6 +5124,10 @@
               <a:prstDash val="dash"/>
             </a:ln>
           </p:spPr>
+          <p:txBody>
+            <a:bodyPr/>
+            <a:p/>
+          </p:txBody>
         </p:sp>
         <p:sp>
           <p:nvSpPr>
@@ -5044,6 +5164,10 @@
               </a:solidFill>
             </a:ln>
           </p:spPr>
+          <p:txBody>
+            <a:bodyPr/>
+            <a:p/>
+          </p:txBody>
         </p:sp>
         <p:sp>
           <p:nvSpPr>
@@ -5121,6 +5245,10 @@
               <a:prstDash val="sysDot"/>
             </a:ln>
           </p:spPr>
+          <p:txBody>
+            <a:bodyPr/>
+            <a:p/>
+          </p:txBody>
         </p:sp>
         <p:sp>
           <p:nvSpPr>
@@ -5184,6 +5312,10 @@
               <a:tailEnd type="triangle" w="lg" len="lg"/>
             </a:ln>
           </p:spPr>
+          <p:txBody>
+            <a:bodyPr/>
+            <a:p/>
+          </p:txBody>
         </p:sp>
       </p:grpSp>
       <p:grpSp>
@@ -5221,6 +5353,10 @@
               <a:noFill/>
             </a:ln>
           </p:spPr>
+          <p:txBody>
+            <a:bodyPr/>
+            <a:p/>
+          </p:txBody>
         </p:sp>
         <p:sp>
           <p:nvSpPr>
@@ -5443,6 +5579,10 @@
               <a:noFill/>
             </a:ln>
           </p:spPr>
+          <p:txBody>
+            <a:bodyPr/>
+            <a:p/>
+          </p:txBody>
         </p:sp>
         <p:sp>
           <p:nvSpPr>
@@ -5665,6 +5805,10 @@
               <a:noFill/>
             </a:ln>
           </p:spPr>
+          <p:txBody>
+            <a:bodyPr/>
+            <a:p/>
+          </p:txBody>
         </p:sp>
         <p:sp>
           <p:nvSpPr>
@@ -5956,6 +6100,10 @@
               </a:solidFill>
             </a:ln>
           </p:spPr>
+          <p:txBody>
+            <a:bodyPr/>
+            <a:p/>
+          </p:txBody>
         </p:sp>
         <p:sp>
           <p:nvSpPr>
@@ -6203,6 +6351,10 @@
               </a:solidFill>
             </a:ln>
           </p:spPr>
+          <p:txBody>
+            <a:bodyPr/>
+            <a:p/>
+          </p:txBody>
         </p:sp>
       </p:grpSp>
       <p:grpSp>
@@ -6375,6 +6527,10 @@
               <a:noFill/>
             </a:ln>
           </p:spPr>
+          <p:txBody>
+            <a:bodyPr/>
+            <a:p/>
+          </p:txBody>
         </p:sp>
         <p:sp>
           <p:nvSpPr>
@@ -6437,6 +6593,10 @@
               <a:noFill/>
             </a:ln>
           </p:spPr>
+          <p:txBody>
+            <a:bodyPr/>
+            <a:p/>
+          </p:txBody>
         </p:sp>
         <p:sp>
           <p:nvSpPr>
@@ -6499,6 +6659,10 @@
               <a:noFill/>
             </a:ln>
           </p:spPr>
+          <p:txBody>
+            <a:bodyPr/>
+            <a:p/>
+          </p:txBody>
         </p:sp>
         <p:sp>
           <p:nvSpPr>
@@ -6561,6 +6725,10 @@
               <a:noFill/>
             </a:ln>
           </p:spPr>
+          <p:txBody>
+            <a:bodyPr/>
+            <a:p/>
+          </p:txBody>
         </p:sp>
         <p:sp>
           <p:nvSpPr>
@@ -6718,6 +6886,10 @@
               <a:noFill/>
             </a:ln>
           </p:spPr>
+          <p:txBody>
+            <a:bodyPr/>
+            <a:p/>
+          </p:txBody>
         </p:sp>
         <p:sp>
           <p:nvSpPr>
@@ -6927,6 +7099,10 @@
               </a:solidFill>
             </a:ln>
           </p:spPr>
+          <p:txBody>
+            <a:bodyPr/>
+            <a:p/>
+          </p:txBody>
         </p:sp>
         <p:sp>
           <p:nvSpPr>
@@ -7058,6 +7234,10 @@
               </a:solidFill>
             </a:ln>
           </p:spPr>
+          <p:txBody>
+            <a:bodyPr/>
+            <a:p/>
+          </p:txBody>
         </p:sp>
         <p:sp>
           <p:nvSpPr>
@@ -7305,6 +7485,10 @@
               </a:solidFill>
             </a:ln>
           </p:spPr>
+          <p:txBody>
+            <a:bodyPr/>
+            <a:p/>
+          </p:txBody>
         </p:sp>
       </p:grpSp>
       <p:grpSp>
@@ -7546,6 +7730,10 @@
               </a:solidFill>
             </a:ln>
           </p:spPr>
+          <p:txBody>
+            <a:bodyPr/>
+            <a:p/>
+          </p:txBody>
         </p:sp>
         <p:sp>
           <p:nvSpPr>
@@ -7662,6 +7850,10 @@
               </a:solidFill>
             </a:ln>
           </p:spPr>
+          <p:txBody>
+            <a:bodyPr/>
+            <a:p/>
+          </p:txBody>
         </p:sp>
         <p:sp>
           <p:nvSpPr>
@@ -7778,6 +7970,10 @@
               </a:solidFill>
             </a:ln>
           </p:spPr>
+          <p:txBody>
+            <a:bodyPr/>
+            <a:p/>
+          </p:txBody>
         </p:sp>
         <p:sp>
           <p:nvSpPr>
@@ -7895,6 +8091,10 @@
               <a:noFill/>
             </a:ln>
           </p:spPr>
+          <p:txBody>
+            <a:bodyPr/>
+            <a:p/>
+          </p:txBody>
         </p:sp>
         <p:sp>
           <p:nvSpPr>
@@ -7957,6 +8157,10 @@
               <a:noFill/>
             </a:ln>
           </p:spPr>
+          <p:txBody>
+            <a:bodyPr/>
+            <a:p/>
+          </p:txBody>
         </p:sp>
         <p:sp>
           <p:nvSpPr>
@@ -8048,6 +8252,10 @@
               </a:solidFill>
             </a:ln>
           </p:spPr>
+          <p:txBody>
+            <a:bodyPr/>
+            <a:p/>
+          </p:txBody>
         </p:sp>
         <p:sp>
           <p:nvSpPr>
@@ -8295,6 +8503,10 @@
               </a:solidFill>
             </a:ln>
           </p:spPr>
+          <p:txBody>
+            <a:bodyPr/>
+            <a:p/>
+          </p:txBody>
         </p:sp>
       </p:grpSp>
       <p:grpSp>
@@ -8441,6 +8653,10 @@
               </a:solidFill>
             </a:ln>
           </p:spPr>
+          <p:txBody>
+            <a:bodyPr/>
+            <a:p/>
+          </p:txBody>
         </p:sp>
         <p:sp>
           <p:nvSpPr>
@@ -8477,6 +8693,10 @@
               </a:solidFill>
             </a:ln>
           </p:spPr>
+          <p:txBody>
+            <a:bodyPr/>
+            <a:p/>
+          </p:txBody>
         </p:sp>
         <p:sp>
           <p:nvSpPr>
@@ -8513,6 +8733,10 @@
               </a:solidFill>
             </a:ln>
           </p:spPr>
+          <p:txBody>
+            <a:bodyPr/>
+            <a:p/>
+          </p:txBody>
         </p:sp>
         <p:sp>
           <p:nvSpPr>
@@ -8549,6 +8773,10 @@
               </a:solidFill>
             </a:ln>
           </p:spPr>
+          <p:txBody>
+            <a:bodyPr/>
+            <a:p/>
+          </p:txBody>
         </p:sp>
         <p:sp>
           <p:nvSpPr>
@@ -8585,6 +8813,10 @@
               </a:solidFill>
             </a:ln>
           </p:spPr>
+          <p:txBody>
+            <a:bodyPr/>
+            <a:p/>
+          </p:txBody>
         </p:sp>
         <p:sp>
           <p:nvSpPr>
@@ -8621,6 +8853,10 @@
               </a:solidFill>
             </a:ln>
           </p:spPr>
+          <p:txBody>
+            <a:bodyPr/>
+            <a:p/>
+          </p:txBody>
         </p:sp>
         <p:sp>
           <p:nvSpPr>
@@ -8657,6 +8893,10 @@
               </a:solidFill>
             </a:ln>
           </p:spPr>
+          <p:txBody>
+            <a:bodyPr/>
+            <a:p/>
+          </p:txBody>
         </p:sp>
         <p:sp>
           <p:nvSpPr>
@@ -8693,6 +8933,10 @@
               </a:solidFill>
             </a:ln>
           </p:spPr>
+          <p:txBody>
+            <a:bodyPr/>
+            <a:p/>
+          </p:txBody>
         </p:sp>
         <p:sp>
           <p:nvSpPr>
@@ -8729,6 +8973,10 @@
               </a:solidFill>
             </a:ln>
           </p:spPr>
+          <p:txBody>
+            <a:bodyPr/>
+            <a:p/>
+          </p:txBody>
         </p:sp>
         <p:sp>
           <p:nvSpPr>
@@ -8765,6 +9013,10 @@
               </a:solidFill>
             </a:ln>
           </p:spPr>
+          <p:txBody>
+            <a:bodyPr/>
+            <a:p/>
+          </p:txBody>
         </p:sp>
         <p:sp>
           <p:nvSpPr>
@@ -8801,6 +9053,10 @@
               </a:solidFill>
             </a:ln>
           </p:spPr>
+          <p:txBody>
+            <a:bodyPr/>
+            <a:p/>
+          </p:txBody>
         </p:sp>
       </p:grpSp>
       <p:grpSp>
@@ -9958,6 +10214,10 @@
               <a:noFill/>
             </a:ln>
           </p:spPr>
+          <p:txBody>
+            <a:bodyPr/>
+            <a:p/>
+          </p:txBody>
         </p:sp>
         <p:sp>
           <p:nvSpPr>
@@ -10129,6 +10389,10 @@
               </a:solidFill>
             </a:ln>
           </p:spPr>
+          <p:txBody>
+            <a:bodyPr/>
+            <a:p/>
+          </p:txBody>
         </p:sp>
         <p:sp>
           <p:nvSpPr>
@@ -10376,6 +10640,10 @@
               </a:solidFill>
             </a:ln>
           </p:spPr>
+          <p:txBody>
+            <a:bodyPr/>
+            <a:p/>
+          </p:txBody>
         </p:sp>
       </p:grpSp>
       <p:grpSp>
@@ -10925,6 +11193,10 @@
               </a:solidFill>
             </a:ln>
           </p:spPr>
+          <p:txBody>
+            <a:bodyPr/>
+            <a:p/>
+          </p:txBody>
         </p:sp>
         <p:sp>
           <p:nvSpPr>
@@ -11122,6 +11394,10 @@
               <a:noFill/>
             </a:ln>
           </p:spPr>
+          <p:txBody>
+            <a:bodyPr/>
+            <a:p/>
+          </p:txBody>
         </p:sp>
         <p:sp>
           <p:nvSpPr>
@@ -11184,6 +11460,10 @@
               <a:noFill/>
             </a:ln>
           </p:spPr>
+          <p:txBody>
+            <a:bodyPr/>
+            <a:p/>
+          </p:txBody>
         </p:sp>
         <p:sp>
           <p:nvSpPr>
@@ -11257,6 +11537,10 @@
               <a:noFill/>
             </a:ln>
           </p:spPr>
+          <p:txBody>
+            <a:bodyPr/>
+            <a:p/>
+          </p:txBody>
         </p:sp>
         <p:sp>
           <p:nvSpPr>
@@ -11319,6 +11603,10 @@
               <a:noFill/>
             </a:ln>
           </p:spPr>
+          <p:txBody>
+            <a:bodyPr/>
+            <a:p/>
+          </p:txBody>
         </p:sp>
         <p:sp>
           <p:nvSpPr>
@@ -11396,6 +11684,10 @@
               <a:noFill/>
             </a:ln>
           </p:spPr>
+          <p:txBody>
+            <a:bodyPr/>
+            <a:p/>
+          </p:txBody>
         </p:sp>
         <p:sp>
           <p:nvSpPr>
@@ -11487,6 +11779,10 @@
               </a:solidFill>
             </a:ln>
           </p:spPr>
+          <p:txBody>
+            <a:bodyPr/>
+            <a:p/>
+          </p:txBody>
         </p:sp>
         <p:sp>
           <p:nvSpPr>
@@ -11734,6 +12030,10 @@
               </a:solidFill>
             </a:ln>
           </p:spPr>
+          <p:txBody>
+            <a:bodyPr/>
+            <a:p/>
+          </p:txBody>
         </p:sp>
       </p:grpSp>
       <p:grpSp>
@@ -12402,6 +12702,10 @@
               </a:solidFill>
             </a:ln>
           </p:spPr>
+          <p:txBody>
+            <a:bodyPr/>
+            <a:p/>
+          </p:txBody>
         </p:sp>
         <p:sp>
           <p:nvSpPr>
@@ -12533,6 +12837,10 @@
               </a:solidFill>
             </a:ln>
           </p:spPr>
+          <p:txBody>
+            <a:bodyPr/>
+            <a:p/>
+          </p:txBody>
         </p:sp>
         <p:sp>
           <p:nvSpPr>
@@ -12780,6 +13088,10 @@
               </a:solidFill>
             </a:ln>
           </p:spPr>
+          <p:txBody>
+            <a:bodyPr/>
+            <a:p/>
+          </p:txBody>
         </p:sp>
       </p:grpSp>
       <p:grpSp>
@@ -12952,6 +13264,10 @@
               <a:noFill/>
             </a:ln>
           </p:spPr>
+          <p:txBody>
+            <a:bodyPr/>
+            <a:p/>
+          </p:txBody>
         </p:sp>
         <p:sp>
           <p:nvSpPr>
@@ -13014,6 +13330,10 @@
               <a:noFill/>
             </a:ln>
           </p:spPr>
+          <p:txBody>
+            <a:bodyPr/>
+            <a:p/>
+          </p:txBody>
         </p:sp>
         <p:sp>
           <p:nvSpPr>
@@ -13076,6 +13396,10 @@
               <a:noFill/>
             </a:ln>
           </p:spPr>
+          <p:txBody>
+            <a:bodyPr/>
+            <a:p/>
+          </p:txBody>
         </p:sp>
         <p:sp>
           <p:nvSpPr>
@@ -13138,6 +13462,10 @@
               <a:noFill/>
             </a:ln>
           </p:spPr>
+          <p:txBody>
+            <a:bodyPr/>
+            <a:p/>
+          </p:txBody>
         </p:sp>
         <p:sp>
           <p:nvSpPr>
@@ -13415,6 +13743,10 @@
               </a:solidFill>
             </a:ln>
           </p:spPr>
+          <p:txBody>
+            <a:bodyPr/>
+            <a:p/>
+          </p:txBody>
         </p:sp>
       </p:grpSp>
       <p:grpSp>
@@ -13466,6 +13798,10 @@
               </a:solidFill>
             </a:ln>
           </p:spPr>
+          <p:txBody>
+            <a:bodyPr/>
+            <a:p/>
+          </p:txBody>
         </p:sp>
         <p:sp>
           <p:nvSpPr>
@@ -13713,6 +14049,10 @@
               </a:solidFill>
             </a:ln>
           </p:spPr>
+          <p:txBody>
+            <a:bodyPr/>
+            <a:p/>
+          </p:txBody>
         </p:sp>
       </p:grpSp>
       <p:grpSp>
@@ -13845,6 +14185,10 @@
               <a:noFill/>
             </a:ln>
           </p:spPr>
+          <p:txBody>
+            <a:bodyPr/>
+            <a:p/>
+          </p:txBody>
         </p:sp>
         <p:sp>
           <p:nvSpPr>
@@ -13947,6 +14291,10 @@
               <a:noFill/>
             </a:ln>
           </p:spPr>
+          <p:txBody>
+            <a:bodyPr/>
+            <a:p/>
+          </p:txBody>
         </p:sp>
         <p:sp>
           <p:nvSpPr>
@@ -14104,6 +14452,10 @@
               <a:noFill/>
             </a:ln>
           </p:spPr>
+          <p:txBody>
+            <a:bodyPr/>
+            <a:p/>
+          </p:txBody>
         </p:sp>
         <p:sp>
           <p:nvSpPr>
@@ -14206,6 +14558,10 @@
               <a:noFill/>
             </a:ln>
           </p:spPr>
+          <p:txBody>
+            <a:bodyPr/>
+            <a:p/>
+          </p:txBody>
         </p:sp>
         <p:sp>
           <p:nvSpPr>
@@ -14363,6 +14719,10 @@
               <a:noFill/>
             </a:ln>
           </p:spPr>
+          <p:txBody>
+            <a:bodyPr/>
+            <a:p/>
+          </p:txBody>
         </p:sp>
         <p:sp>
           <p:nvSpPr>
@@ -14465,6 +14825,10 @@
               <a:noFill/>
             </a:ln>
           </p:spPr>
+          <p:txBody>
+            <a:bodyPr/>
+            <a:p/>
+          </p:txBody>
         </p:sp>
         <p:sp>
           <p:nvSpPr>
@@ -14676,6 +15040,10 @@
               </a:solidFill>
             </a:ln>
           </p:spPr>
+          <p:txBody>
+            <a:bodyPr/>
+            <a:p/>
+          </p:txBody>
         </p:sp>
         <p:sp>
           <p:nvSpPr>
@@ -14923,6 +15291,10 @@
               </a:solidFill>
             </a:ln>
           </p:spPr>
+          <p:txBody>
+            <a:bodyPr/>
+            <a:p/>
+          </p:txBody>
         </p:sp>
       </p:grpSp>
       <p:grpSp>
@@ -15040,6 +15412,10 @@
               <a:noFill/>
             </a:ln>
           </p:spPr>
+          <p:txBody>
+            <a:bodyPr/>
+            <a:p/>
+          </p:txBody>
         </p:sp>
       </p:grpSp>
       <p:grpSp>
@@ -15172,6 +15548,10 @@
               </a:solidFill>
             </a:ln>
           </p:spPr>
+          <p:txBody>
+            <a:bodyPr/>
+            <a:p/>
+          </p:txBody>
         </p:sp>
         <p:sp>
           <p:nvSpPr>
@@ -15194,6 +15574,10 @@
               </a:solidFill>
             </a:ln>
           </p:spPr>
+          <p:txBody>
+            <a:bodyPr/>
+            <a:p/>
+          </p:txBody>
         </p:sp>
         <p:sp>
           <p:nvSpPr>
@@ -15216,6 +15600,10 @@
               <a:noFill/>
             </a:ln>
           </p:spPr>
+          <p:txBody>
+            <a:bodyPr/>
+            <a:p/>
+          </p:txBody>
         </p:sp>
         <p:sp>
           <p:nvSpPr>
@@ -15238,6 +15626,10 @@
               <a:noFill/>
             </a:ln>
           </p:spPr>
+          <p:txBody>
+            <a:bodyPr/>
+            <a:p/>
+          </p:txBody>
         </p:sp>
         <p:sp>
           <p:nvSpPr>
@@ -15260,6 +15652,10 @@
               <a:noFill/>
             </a:ln>
           </p:spPr>
+          <p:txBody>
+            <a:bodyPr/>
+            <a:p/>
+          </p:txBody>
         </p:sp>
         <p:sp>
           <p:nvSpPr>
@@ -15282,6 +15678,10 @@
               <a:noFill/>
             </a:ln>
           </p:spPr>
+          <p:txBody>
+            <a:bodyPr/>
+            <a:p/>
+          </p:txBody>
         </p:sp>
         <p:sp>
           <p:nvSpPr>
@@ -15304,6 +15704,10 @@
               <a:noFill/>
             </a:ln>
           </p:spPr>
+          <p:txBody>
+            <a:bodyPr/>
+            <a:p/>
+          </p:txBody>
         </p:sp>
         <p:sp>
           <p:nvSpPr>
@@ -15326,6 +15730,10 @@
               <a:noFill/>
             </a:ln>
           </p:spPr>
+          <p:txBody>
+            <a:bodyPr/>
+            <a:p/>
+          </p:txBody>
         </p:sp>
         <p:sp>
           <p:nvSpPr>
@@ -15348,6 +15756,10 @@
               <a:noFill/>
             </a:ln>
           </p:spPr>
+          <p:txBody>
+            <a:bodyPr/>
+            <a:p/>
+          </p:txBody>
         </p:sp>
         <p:sp>
           <p:nvSpPr>
@@ -15370,6 +15782,10 @@
               <a:noFill/>
             </a:ln>
           </p:spPr>
+          <p:txBody>
+            <a:bodyPr/>
+            <a:p/>
+          </p:txBody>
         </p:sp>
         <p:sp>
           <p:nvSpPr>
@@ -15392,6 +15808,10 @@
               <a:noFill/>
             </a:ln>
           </p:spPr>
+          <p:txBody>
+            <a:bodyPr/>
+            <a:p/>
+          </p:txBody>
         </p:sp>
         <p:sp>
           <p:nvSpPr>
@@ -15483,6 +15903,10 @@
               </a:solidFill>
             </a:ln>
           </p:spPr>
+          <p:txBody>
+            <a:bodyPr/>
+            <a:p/>
+          </p:txBody>
         </p:sp>
         <p:sp>
           <p:nvSpPr>
@@ -15730,6 +16154,10 @@
               </a:solidFill>
             </a:ln>
           </p:spPr>
+          <p:txBody>
+            <a:bodyPr/>
+            <a:p/>
+          </p:txBody>
         </p:sp>
       </p:grpSp>
       <p:grpSp>
@@ -15767,6 +16195,10 @@
               <a:noFill/>
             </a:ln>
           </p:spPr>
+          <p:txBody>
+            <a:bodyPr/>
+            <a:p/>
+          </p:txBody>
         </p:sp>
         <p:sp>
           <p:nvSpPr>
@@ -15884,6 +16316,10 @@
               <a:noFill/>
             </a:ln>
           </p:spPr>
+          <p:txBody>
+            <a:bodyPr/>
+            <a:p/>
+          </p:txBody>
         </p:sp>
         <p:sp>
           <p:nvSpPr>
@@ -15906,6 +16342,10 @@
               <a:noFill/>
             </a:ln>
           </p:spPr>
+          <p:txBody>
+            <a:bodyPr/>
+            <a:p/>
+          </p:txBody>
         </p:sp>
         <p:sp>
           <p:nvSpPr>
@@ -16103,6 +16543,10 @@
               <a:noFill/>
             </a:ln>
           </p:spPr>
+          <p:txBody>
+            <a:bodyPr/>
+            <a:p/>
+          </p:txBody>
         </p:sp>
         <p:sp>
           <p:nvSpPr>
@@ -16125,6 +16569,10 @@
               <a:noFill/>
             </a:ln>
           </p:spPr>
+          <p:txBody>
+            <a:bodyPr/>
+            <a:p/>
+          </p:txBody>
         </p:sp>
         <p:sp>
           <p:nvSpPr>
@@ -16344,6 +16792,10 @@
               <a:noFill/>
             </a:ln>
           </p:spPr>
+          <p:txBody>
+            <a:bodyPr/>
+            <a:p/>
+          </p:txBody>
         </p:sp>
         <p:sp>
           <p:nvSpPr>
@@ -16366,6 +16818,10 @@
               <a:noFill/>
             </a:ln>
           </p:spPr>
+          <p:txBody>
+            <a:bodyPr/>
+            <a:p/>
+          </p:txBody>
         </p:sp>
         <p:sp>
           <p:nvSpPr>
@@ -16563,6 +17019,10 @@
               <a:noFill/>
             </a:ln>
           </p:spPr>
+          <p:txBody>
+            <a:bodyPr/>
+            <a:p/>
+          </p:txBody>
         </p:sp>
         <p:sp>
           <p:nvSpPr>
@@ -16585,6 +17045,10 @@
               <a:noFill/>
             </a:ln>
           </p:spPr>
+          <p:txBody>
+            <a:bodyPr/>
+            <a:p/>
+          </p:txBody>
         </p:sp>
         <p:sp>
           <p:nvSpPr>
@@ -16782,6 +17246,10 @@
               <a:noFill/>
             </a:ln>
           </p:spPr>
+          <p:txBody>
+            <a:bodyPr/>
+            <a:p/>
+          </p:txBody>
         </p:sp>
         <p:sp>
           <p:nvSpPr>
@@ -16804,6 +17272,10 @@
               <a:noFill/>
             </a:ln>
           </p:spPr>
+          <p:txBody>
+            <a:bodyPr/>
+            <a:p/>
+          </p:txBody>
         </p:sp>
         <p:sp>
           <p:nvSpPr>
@@ -17015,6 +17487,10 @@
               </a:solidFill>
             </a:ln>
           </p:spPr>
+          <p:txBody>
+            <a:bodyPr/>
+            <a:p/>
+          </p:txBody>
         </p:sp>
         <p:sp>
           <p:nvSpPr>
@@ -17262,6 +17738,10 @@
               </a:solidFill>
             </a:ln>
           </p:spPr>
+          <p:txBody>
+            <a:bodyPr/>
+            <a:p/>
+          </p:txBody>
         </p:sp>
       </p:grpSp>
       <p:grpSp>
@@ -17459,6 +17939,10 @@
               <a:noFill/>
             </a:ln>
           </p:spPr>
+          <p:txBody>
+            <a:bodyPr/>
+            <a:p/>
+          </p:txBody>
         </p:sp>
         <p:sp>
           <p:nvSpPr>
@@ -17561,6 +18045,10 @@
               <a:noFill/>
             </a:ln>
           </p:spPr>
+          <p:txBody>
+            <a:bodyPr/>
+            <a:p/>
+          </p:txBody>
         </p:sp>
         <p:sp>
           <p:nvSpPr>
@@ -17663,6 +18151,10 @@
               <a:noFill/>
             </a:ln>
           </p:spPr>
+          <p:txBody>
+            <a:bodyPr/>
+            <a:p/>
+          </p:txBody>
         </p:sp>
         <p:sp>
           <p:nvSpPr>
@@ -17765,6 +18257,10 @@
               <a:noFill/>
             </a:ln>
           </p:spPr>
+          <p:txBody>
+            <a:bodyPr/>
+            <a:p/>
+          </p:txBody>
         </p:sp>
         <p:sp>
           <p:nvSpPr>
@@ -17936,6 +18432,10 @@
               </a:solidFill>
             </a:ln>
           </p:spPr>
+          <p:txBody>
+            <a:bodyPr/>
+            <a:p/>
+          </p:txBody>
         </p:sp>
         <p:sp>
           <p:nvSpPr>
@@ -18092,6 +18592,10 @@
               </a:solidFill>
             </a:ln>
           </p:spPr>
+          <p:txBody>
+            <a:bodyPr/>
+            <a:p/>
+          </p:txBody>
         </p:sp>
         <p:sp>
           <p:nvSpPr>
@@ -18248,6 +18752,10 @@
               </a:solidFill>
             </a:ln>
           </p:spPr>
+          <p:txBody>
+            <a:bodyPr/>
+            <a:p/>
+          </p:txBody>
         </p:sp>
         <p:sp>
           <p:nvSpPr>
@@ -18404,6 +18912,10 @@
               </a:solidFill>
             </a:ln>
           </p:spPr>
+          <p:txBody>
+            <a:bodyPr/>
+            <a:p/>
+          </p:txBody>
         </p:sp>
         <p:sp>
           <p:nvSpPr>
@@ -18561,6 +19073,10 @@
               <a:noFill/>
             </a:ln>
           </p:spPr>
+          <p:txBody>
+            <a:bodyPr/>
+            <a:p/>
+          </p:txBody>
         </p:sp>
         <p:sp>
           <p:nvSpPr>
@@ -18692,6 +19208,10 @@
               </a:solidFill>
             </a:ln>
           </p:spPr>
+          <p:txBody>
+            <a:bodyPr/>
+            <a:p/>
+          </p:txBody>
         </p:sp>
         <p:sp>
           <p:nvSpPr>
@@ -18939,6 +19459,10 @@
               </a:solidFill>
             </a:ln>
           </p:spPr>
+          <p:txBody>
+            <a:bodyPr/>
+            <a:p/>
+          </p:txBody>
         </p:sp>
       </p:grpSp>
       <p:grpSp>
@@ -19229,6 +19753,10 @@
               <a:tailEnd type="triangle" w="lg" len="lg"/>
             </a:ln>
           </p:spPr>
+          <p:txBody>
+            <a:bodyPr/>
+            <a:p/>
+          </p:txBody>
         </p:sp>
         <p:sp>
           <p:nvSpPr>
@@ -19265,6 +19793,10 @@
               </a:solidFill>
             </a:ln>
           </p:spPr>
+          <p:txBody>
+            <a:bodyPr/>
+            <a:p/>
+          </p:txBody>
         </p:sp>
         <p:sp>
           <p:nvSpPr>
@@ -19301,6 +19833,10 @@
               </a:solidFill>
             </a:ln>
           </p:spPr>
+          <p:txBody>
+            <a:bodyPr/>
+            <a:p/>
+          </p:txBody>
         </p:sp>
         <p:sp>
           <p:nvSpPr>
@@ -19337,6 +19873,10 @@
               </a:solidFill>
             </a:ln>
           </p:spPr>
+          <p:txBody>
+            <a:bodyPr/>
+            <a:p/>
+          </p:txBody>
         </p:sp>
         <p:sp>
           <p:nvSpPr>
@@ -19373,6 +19913,10 @@
               </a:solidFill>
             </a:ln>
           </p:spPr>
+          <p:txBody>
+            <a:bodyPr/>
+            <a:p/>
+          </p:txBody>
         </p:sp>
         <p:sp>
           <p:nvSpPr>
@@ -19555,6 +20099,10 @@
               <a:noFill/>
             </a:ln>
           </p:spPr>
+          <p:txBody>
+            <a:bodyPr/>
+            <a:p/>
+          </p:txBody>
         </p:sp>
         <p:sp>
           <p:nvSpPr>
@@ -19577,6 +20125,10 @@
               <a:noFill/>
             </a:ln>
           </p:spPr>
+          <p:txBody>
+            <a:bodyPr/>
+            <a:p/>
+          </p:txBody>
         </p:sp>
         <p:sp>
           <p:nvSpPr>
@@ -19613,6 +20165,10 @@
               </a:solidFill>
             </a:ln>
           </p:spPr>
+          <p:txBody>
+            <a:bodyPr/>
+            <a:p/>
+          </p:txBody>
         </p:sp>
         <p:sp>
           <p:nvSpPr>
@@ -19690,6 +20246,10 @@
               <a:noFill/>
             </a:ln>
           </p:spPr>
+          <p:txBody>
+            <a:bodyPr/>
+            <a:p/>
+          </p:txBody>
         </p:sp>
         <p:sp>
           <p:nvSpPr>
@@ -19817,6 +20377,10 @@
               <a:noFill/>
             </a:ln>
           </p:spPr>
+          <p:txBody>
+            <a:bodyPr/>
+            <a:p/>
+          </p:txBody>
         </p:sp>
         <p:sp>
           <p:nvSpPr>
@@ -19973,6 +20537,10 @@
               </a:solidFill>
             </a:ln>
           </p:spPr>
+          <p:txBody>
+            <a:bodyPr/>
+            <a:p/>
+          </p:txBody>
         </p:sp>
         <p:sp>
           <p:nvSpPr>
@@ -20220,6 +20788,10 @@
               </a:solidFill>
             </a:ln>
           </p:spPr>
+          <p:txBody>
+            <a:bodyPr/>
+            <a:p/>
+          </p:txBody>
         </p:sp>
       </p:grpSp>
       <p:grpSp>
@@ -20352,6 +20924,10 @@
               <a:noFill/>
             </a:ln>
           </p:spPr>
+          <p:txBody>
+            <a:bodyPr/>
+            <a:p/>
+          </p:txBody>
         </p:sp>
         <p:sp>
           <p:nvSpPr>
@@ -20454,6 +21030,10 @@
               <a:noFill/>
             </a:ln>
           </p:spPr>
+          <p:txBody>
+            <a:bodyPr/>
+            <a:p/>
+          </p:txBody>
         </p:sp>
         <p:sp>
           <p:nvSpPr>
@@ -20476,6 +21056,10 @@
               <a:noFill/>
             </a:ln>
           </p:spPr>
+          <p:txBody>
+            <a:bodyPr/>
+            <a:p/>
+          </p:txBody>
         </p:sp>
         <p:sp>
           <p:nvSpPr>
@@ -20578,6 +21162,10 @@
               <a:noFill/>
             </a:ln>
           </p:spPr>
+          <p:txBody>
+            <a:bodyPr/>
+            <a:p/>
+          </p:txBody>
         </p:sp>
         <p:sp>
           <p:nvSpPr>
@@ -20682,6 +21270,10 @@
               </a:solidFill>
             </a:ln>
           </p:spPr>
+          <p:txBody>
+            <a:bodyPr/>
+            <a:p/>
+          </p:txBody>
         </p:sp>
         <p:sp>
           <p:nvSpPr>
@@ -20839,6 +21431,10 @@
               <a:noFill/>
             </a:ln>
           </p:spPr>
+          <p:txBody>
+            <a:bodyPr/>
+            <a:p/>
+          </p:txBody>
         </p:sp>
         <p:sp>
           <p:nvSpPr>
@@ -20912,6 +21508,10 @@
               <a:noFill/>
             </a:ln>
           </p:spPr>
+          <p:txBody>
+            <a:bodyPr/>
+            <a:p/>
+          </p:txBody>
         </p:sp>
         <p:sp>
           <p:nvSpPr>
@@ -20974,6 +21574,10 @@
               <a:noFill/>
             </a:ln>
           </p:spPr>
+          <p:txBody>
+            <a:bodyPr/>
+            <a:p/>
+          </p:txBody>
         </p:sp>
         <p:sp>
           <p:nvSpPr>
@@ -21051,6 +21655,10 @@
               <a:noFill/>
             </a:ln>
           </p:spPr>
+          <p:txBody>
+            <a:bodyPr/>
+            <a:p/>
+          </p:txBody>
         </p:sp>
         <p:sp>
           <p:nvSpPr>
@@ -21142,6 +21750,10 @@
               </a:solidFill>
             </a:ln>
           </p:spPr>
+          <p:txBody>
+            <a:bodyPr/>
+            <a:p/>
+          </p:txBody>
         </p:sp>
         <p:sp>
           <p:nvSpPr>
@@ -21389,6 +22001,10 @@
               </a:solidFill>
             </a:ln>
           </p:spPr>
+          <p:txBody>
+            <a:bodyPr/>
+            <a:p/>
+          </p:txBody>
         </p:sp>
       </p:grpSp>
       <p:grpSp>
@@ -21521,6 +22137,10 @@
               <a:noFill/>
             </a:ln>
           </p:spPr>
+          <p:txBody>
+            <a:bodyPr/>
+            <a:p/>
+          </p:txBody>
         </p:sp>
         <p:sp>
           <p:nvSpPr>
@@ -21640,6 +22260,10 @@
               </a:solidFill>
             </a:ln>
           </p:spPr>
+          <p:txBody>
+            <a:bodyPr/>
+            <a:p/>
+          </p:txBody>
         </p:sp>
         <p:sp>
           <p:nvSpPr>
@@ -21757,6 +22381,10 @@
               <a:noFill/>
             </a:ln>
           </p:spPr>
+          <p:txBody>
+            <a:bodyPr/>
+            <a:p/>
+          </p:txBody>
         </p:sp>
         <p:sp>
           <p:nvSpPr>
@@ -21874,6 +22502,10 @@
               <a:noFill/>
             </a:ln>
           </p:spPr>
+          <p:txBody>
+            <a:bodyPr/>
+            <a:p/>
+          </p:txBody>
         </p:sp>
         <p:sp>
           <p:nvSpPr>
@@ -21991,6 +22623,10 @@
               <a:noFill/>
             </a:ln>
           </p:spPr>
+          <p:txBody>
+            <a:bodyPr/>
+            <a:p/>
+          </p:txBody>
         </p:sp>
         <p:sp>
           <p:nvSpPr>
@@ -22108,6 +22744,10 @@
               <a:noFill/>
             </a:ln>
           </p:spPr>
+          <p:txBody>
+            <a:bodyPr/>
+            <a:p/>
+          </p:txBody>
         </p:sp>
         <p:sp>
           <p:nvSpPr>
@@ -22225,6 +22865,10 @@
               <a:noFill/>
             </a:ln>
           </p:spPr>
+          <p:txBody>
+            <a:bodyPr/>
+            <a:p/>
+          </p:txBody>
         </p:sp>
         <p:sp>
           <p:nvSpPr>
@@ -22342,6 +22986,10 @@
               <a:noFill/>
             </a:ln>
           </p:spPr>
+          <p:txBody>
+            <a:bodyPr/>
+            <a:p/>
+          </p:txBody>
         </p:sp>
         <p:sp>
           <p:nvSpPr>
@@ -22445,6 +23093,10 @@
             <a:noFill/>
           </a:ln>
         </p:spPr>
+        <p:txBody>
+          <a:bodyPr/>
+          <a:p/>
+        </p:txBody>
       </p:sp>
       <p:sp>
         <p:nvSpPr>
@@ -22467,6 +23119,10 @@
             <a:noFill/>
           </a:ln>
         </p:spPr>
+        <p:txBody>
+          <a:bodyPr/>
+          <a:p/>
+        </p:txBody>
       </p:sp>
       <p:sp>
         <p:nvSpPr>
@@ -22489,6 +23145,10 @@
             <a:noFill/>
           </a:ln>
         </p:spPr>
+        <p:txBody>
+          <a:bodyPr/>
+          <a:p/>
+        </p:txBody>
       </p:sp>
       <p:sp>
         <p:nvSpPr>
@@ -22511,6 +23171,10 @@
             <a:noFill/>
           </a:ln>
         </p:spPr>
+        <p:txBody>
+          <a:bodyPr/>
+          <a:p/>
+        </p:txBody>
       </p:sp>
       <p:sp>
         <p:nvSpPr>
@@ -22533,6 +23197,10 @@
             <a:noFill/>
           </a:ln>
         </p:spPr>
+        <p:txBody>
+          <a:bodyPr/>
+          <a:p/>
+        </p:txBody>
       </p:sp>
       <p:sp>
         <p:nvSpPr>
@@ -22555,6 +23223,10 @@
             <a:noFill/>
           </a:ln>
         </p:spPr>
+        <p:txBody>
+          <a:bodyPr/>
+          <a:p/>
+        </p:txBody>
       </p:sp>
       <p:grpSp>
         <p:nvGrpSpPr>
@@ -22605,6 +23277,10 @@
               </a:solidFill>
             </a:ln>
           </p:spPr>
+          <p:txBody>
+            <a:bodyPr/>
+            <a:p/>
+          </p:txBody>
         </p:sp>
         <p:sp>
           <p:nvSpPr>
@@ -22641,6 +23317,10 @@
               </a:solidFill>
             </a:ln>
           </p:spPr>
+          <p:txBody>
+            <a:bodyPr/>
+            <a:p/>
+          </p:txBody>
         </p:sp>
         <p:sp>
           <p:nvSpPr>
@@ -22664,6 +23344,10 @@
               <a:tailEnd type="triangle" w="lg" len="lg"/>
             </a:ln>
           </p:spPr>
+          <p:txBody>
+            <a:bodyPr/>
+            <a:p/>
+          </p:txBody>
         </p:sp>
       </p:grpSp>
       <p:grpSp>
@@ -22701,6 +23385,10 @@
               <a:noFill/>
             </a:ln>
           </p:spPr>
+          <p:txBody>
+            <a:bodyPr/>
+            <a:p/>
+          </p:txBody>
         </p:sp>
         <p:sp>
           <p:nvSpPr>
@@ -22854,6 +23542,10 @@
               </a:solidFill>
             </a:ln>
           </p:spPr>
+          <p:txBody>
+            <a:bodyPr/>
+            <a:p/>
+          </p:txBody>
         </p:sp>
         <p:sp>
           <p:nvSpPr>
@@ -23101,6 +23793,10 @@
               </a:solidFill>
             </a:ln>
           </p:spPr>
+          <p:txBody>
+            <a:bodyPr/>
+            <a:p/>
+          </p:txBody>
         </p:sp>
       </p:grpSp>
       <p:grpSp>
@@ -23273,6 +23969,10 @@
               <a:noFill/>
             </a:ln>
           </p:spPr>
+          <p:txBody>
+            <a:bodyPr/>
+            <a:p/>
+          </p:txBody>
         </p:sp>
         <p:sp>
           <p:nvSpPr>
@@ -23335,6 +24035,10 @@
               <a:noFill/>
             </a:ln>
           </p:spPr>
+          <p:txBody>
+            <a:bodyPr/>
+            <a:p/>
+          </p:txBody>
         </p:sp>
         <p:sp>
           <p:nvSpPr>
@@ -23397,6 +24101,10 @@
               <a:noFill/>
             </a:ln>
           </p:spPr>
+          <p:txBody>
+            <a:bodyPr/>
+            <a:p/>
+          </p:txBody>
         </p:sp>
         <p:sp>
           <p:nvSpPr>
@@ -23473,6 +24181,10 @@
               </a:solidFill>
             </a:ln>
           </p:spPr>
+          <p:txBody>
+            <a:bodyPr/>
+            <a:p/>
+          </p:txBody>
         </p:sp>
         <p:sp>
           <p:nvSpPr>
@@ -23509,6 +24221,10 @@
               </a:solidFill>
             </a:ln>
           </p:spPr>
+          <p:txBody>
+            <a:bodyPr/>
+            <a:p/>
+          </p:txBody>
         </p:sp>
         <p:sp>
           <p:nvSpPr>
@@ -23546,6 +24262,10 @@
               <a:prstDash val="lgDash"/>
             </a:ln>
           </p:spPr>
+          <p:txBody>
+            <a:bodyPr/>
+            <a:p/>
+          </p:txBody>
         </p:sp>
         <p:sp>
           <p:nvSpPr>
@@ -23783,6 +24503,10 @@
               <a:noFill/>
             </a:ln>
           </p:spPr>
+          <p:txBody>
+            <a:bodyPr/>
+            <a:p/>
+          </p:txBody>
         </p:sp>
         <p:sp>
           <p:nvSpPr>
@@ -23885,6 +24609,10 @@
               <a:noFill/>
             </a:ln>
           </p:spPr>
+          <p:txBody>
+            <a:bodyPr/>
+            <a:p/>
+          </p:txBody>
         </p:sp>
         <p:sp>
           <p:nvSpPr>
@@ -24056,6 +24784,10 @@
               </a:solidFill>
             </a:ln>
           </p:spPr>
+          <p:txBody>
+            <a:bodyPr/>
+            <a:p/>
+          </p:txBody>
         </p:sp>
         <p:sp>
           <p:nvSpPr>
@@ -24303,6 +25035,10 @@
               </a:solidFill>
             </a:ln>
           </p:spPr>
+          <p:txBody>
+            <a:bodyPr/>
+            <a:p/>
+          </p:txBody>
         </p:sp>
       </p:grpSp>
       <p:grpSp>
@@ -24475,6 +25211,10 @@
               <a:noFill/>
             </a:ln>
           </p:spPr>
+          <p:txBody>
+            <a:bodyPr/>
+            <a:p/>
+          </p:txBody>
         </p:sp>
         <p:sp>
           <p:nvSpPr>
@@ -24577,6 +25317,10 @@
               <a:noFill/>
             </a:ln>
           </p:spPr>
+          <p:txBody>
+            <a:bodyPr/>
+            <a:p/>
+          </p:txBody>
         </p:sp>
         <p:sp>
           <p:nvSpPr>
@@ -24679,6 +25423,10 @@
               <a:noFill/>
             </a:ln>
           </p:spPr>
+          <p:txBody>
+            <a:bodyPr/>
+            <a:p/>
+          </p:txBody>
         </p:sp>
         <p:sp>
           <p:nvSpPr>
@@ -24796,6 +25544,10 @@
               <a:noFill/>
             </a:ln>
           </p:spPr>
+          <p:txBody>
+            <a:bodyPr/>
+            <a:p/>
+          </p:txBody>
         </p:sp>
         <p:sp>
           <p:nvSpPr>
@@ -24940,6 +25692,10 @@
               </a:solidFill>
             </a:ln>
           </p:spPr>
+          <p:txBody>
+            <a:bodyPr/>
+            <a:p/>
+          </p:txBody>
         </p:sp>
         <p:sp>
           <p:nvSpPr>
@@ -25097,6 +25853,10 @@
               <a:noFill/>
             </a:ln>
           </p:spPr>
+          <p:txBody>
+            <a:bodyPr/>
+            <a:p/>
+          </p:txBody>
         </p:sp>
         <p:sp>
           <p:nvSpPr>
@@ -25228,6 +25988,10 @@
               </a:solidFill>
             </a:ln>
           </p:spPr>
+          <p:txBody>
+            <a:bodyPr/>
+            <a:p/>
+          </p:txBody>
         </p:sp>
         <p:sp>
           <p:nvSpPr>
@@ -25475,6 +26239,10 @@
               </a:solidFill>
             </a:ln>
           </p:spPr>
+          <p:txBody>
+            <a:bodyPr/>
+            <a:p/>
+          </p:txBody>
         </p:sp>
       </p:grpSp>
       <p:grpSp>
@@ -25607,6 +26375,10 @@
               <a:noFill/>
             </a:ln>
           </p:spPr>
+          <p:txBody>
+            <a:bodyPr/>
+            <a:p/>
+          </p:txBody>
         </p:sp>
         <p:sp>
           <p:nvSpPr>
@@ -25909,6 +26681,10 @@
               <a:noFill/>
             </a:ln>
           </p:spPr>
+          <p:txBody>
+            <a:bodyPr/>
+            <a:p/>
+          </p:txBody>
         </p:sp>
         <p:sp>
           <p:nvSpPr>
@@ -26091,6 +26867,10 @@
               <a:noFill/>
             </a:ln>
           </p:spPr>
+          <p:txBody>
+            <a:bodyPr/>
+            <a:p/>
+          </p:txBody>
         </p:sp>
         <p:sp>
           <p:nvSpPr>
@@ -26648,6 +27428,10 @@
               <a:noFill/>
             </a:ln>
           </p:spPr>
+          <p:txBody>
+            <a:bodyPr/>
+            <a:p/>
+          </p:txBody>
         </p:sp>
         <p:sp>
           <p:nvSpPr>
@@ -27205,6 +27989,10 @@
               <a:noFill/>
             </a:ln>
           </p:spPr>
+          <p:txBody>
+            <a:bodyPr/>
+            <a:p/>
+          </p:txBody>
         </p:sp>
         <p:sp>
           <p:nvSpPr>
@@ -27296,6 +28084,10 @@
               </a:solidFill>
             </a:ln>
           </p:spPr>
+          <p:txBody>
+            <a:bodyPr/>
+            <a:p/>
+          </p:txBody>
         </p:sp>
         <p:sp>
           <p:nvSpPr>

</xml_diff>